<commit_message>
Week 0 Thursday decks: restore the > signs in four diagram labels
Both halves are rebuilt with the fixed renderer. Slide D10 of half one now puts
its diagram after the caption, since the wider labels had pushed the builder
into a layout that set the SQL at its smallest size. The provenance note records
the change after review-1.

Co-Authored-By: Claude Opus 5.5 <noreply@anthropic.com>
Claude-Session: https://claude.ai/code/session_01P7zaoR4dQ5pzBFnsX549JQ
</commit_message>
<xml_diff>
--- a/content/W00/D4/slides/C2_W00_D04_half1_STUDENT.pptx
+++ b/content/W00/D4/slides/C2_W00_D04_half1_STUDENT.pptx
@@ -5793,9 +5793,223 @@
           </a:p>
         </p:txBody>
       </p:sp>
+      <p:sp>
+        <p:nvSpPr>
+          <p:cNvPr id="7" name="Rectangle 6"/>
+          <p:cNvSpPr/>
+          <p:nvPr/>
+        </p:nvSpPr>
+        <p:spPr>
+          <a:xfrm>
+            <a:off x="685800" y="1627632"/>
+            <a:ext cx="10820095" cy="1265936"/>
+          </a:xfrm>
+          <a:prstGeom prst="rect">
+            <a:avLst/>
+          </a:prstGeom>
+          <a:solidFill>
+            <a:srgbClr val="1C1C1A"/>
+          </a:solidFill>
+          <a:ln>
+            <a:noFill/>
+          </a:ln>
+          <a:effectLst/>
+        </p:spPr>
+        <p:style>
+          <a:lnRef idx="1">
+            <a:schemeClr val="accent1"/>
+          </a:lnRef>
+          <a:fillRef idx="3">
+            <a:schemeClr val="accent1"/>
+          </a:fillRef>
+          <a:effectRef idx="2">
+            <a:schemeClr val="accent1"/>
+          </a:effectRef>
+          <a:fontRef idx="minor">
+            <a:schemeClr val="lt1"/>
+          </a:fontRef>
+        </p:style>
+        <p:txBody>
+          <a:bodyPr rtlCol="0" anchor="ctr" wrap="square"/>
+          <a:lstStyle/>
+          <a:p>
+            <a:pPr algn="ctr"/>
+          </a:p>
+        </p:txBody>
+      </p:sp>
+      <p:sp>
+        <p:nvSpPr>
+          <p:cNvPr id="8" name="Rectangle 7"/>
+          <p:cNvSpPr/>
+          <p:nvPr/>
+        </p:nvSpPr>
+        <p:spPr>
+          <a:xfrm>
+            <a:off x="685800" y="1627632"/>
+            <a:ext cx="50292" cy="1265936"/>
+          </a:xfrm>
+          <a:prstGeom prst="rect">
+            <a:avLst/>
+          </a:prstGeom>
+          <a:solidFill>
+            <a:srgbClr val="2B4A7D"/>
+          </a:solidFill>
+          <a:ln>
+            <a:noFill/>
+          </a:ln>
+          <a:effectLst/>
+        </p:spPr>
+        <p:style>
+          <a:lnRef idx="1">
+            <a:schemeClr val="accent1"/>
+          </a:lnRef>
+          <a:fillRef idx="3">
+            <a:schemeClr val="accent1"/>
+          </a:fillRef>
+          <a:effectRef idx="2">
+            <a:schemeClr val="accent1"/>
+          </a:effectRef>
+          <a:fontRef idx="minor">
+            <a:schemeClr val="lt1"/>
+          </a:fontRef>
+        </p:style>
+        <p:txBody>
+          <a:bodyPr rtlCol="0" anchor="ctr" wrap="square"/>
+          <a:lstStyle/>
+          <a:p>
+            <a:pPr algn="ctr"/>
+          </a:p>
+        </p:txBody>
+      </p:sp>
+      <p:sp>
+        <p:nvSpPr>
+          <p:cNvPr id="9" name="TextBox 8"/>
+          <p:cNvSpPr txBox="1"/>
+          <p:nvPr/>
+        </p:nvSpPr>
+        <p:spPr>
+          <a:xfrm>
+            <a:off x="923544" y="1728216"/>
+            <a:ext cx="10417759" cy="1083056"/>
+          </a:xfrm>
+          <a:prstGeom prst="rect">
+            <a:avLst/>
+          </a:prstGeom>
+          <a:noFill/>
+        </p:spPr>
+        <p:txBody>
+          <a:bodyPr wrap="square" anchor="t" lIns="0" rIns="0" tIns="0" bIns="0">
+            <a:spAutoFit/>
+          </a:bodyPr>
+          <a:lstStyle/>
+          <a:p>
+            <a:pPr>
+              <a:spcAft>
+                <a:spcPts val="200"/>
+              </a:spcAft>
+            </a:pPr>
+            <a:r>
+              <a:rPr sz="1400" b="0">
+                <a:solidFill>
+                  <a:srgbClr val="E4ECF7"/>
+                </a:solidFill>
+                <a:latin typeface="Consolas"/>
+              </a:rPr>
+              <a:t>SELECT SUM(days_kept - 14) AS late_days</a:t>
+            </a:r>
+          </a:p>
+          <a:p>
+            <a:pPr>
+              <a:spcAft>
+                <a:spcPts val="200"/>
+              </a:spcAft>
+            </a:pPr>
+            <a:r>
+              <a:rPr sz="1400" b="0">
+                <a:solidFill>
+                  <a:srgbClr val="E4ECF7"/>
+                </a:solidFill>
+                <a:latin typeface="Consolas"/>
+              </a:rPr>
+              <a:t>FROM issues</a:t>
+            </a:r>
+          </a:p>
+          <a:p>
+            <a:pPr>
+              <a:spcAft>
+                <a:spcPts val="200"/>
+              </a:spcAft>
+            </a:pPr>
+            <a:r>
+              <a:rPr sz="1400" b="0">
+                <a:solidFill>
+                  <a:srgbClr val="E4ECF7"/>
+                </a:solidFill>
+                <a:latin typeface="Consolas"/>
+              </a:rPr>
+              <a:t>WHERE week = 1</a:t>
+            </a:r>
+          </a:p>
+          <a:p>
+            <a:pPr>
+              <a:spcAft>
+                <a:spcPts val="200"/>
+              </a:spcAft>
+            </a:pPr>
+            <a:r>
+              <a:rPr sz="1400" b="0">
+                <a:solidFill>
+                  <a:srgbClr val="E4ECF7"/>
+                </a:solidFill>
+                <a:latin typeface="Consolas"/>
+              </a:rPr>
+              <a:t>  AND days_kept &gt; 14;        -- 13</a:t>
+            </a:r>
+          </a:p>
+        </p:txBody>
+      </p:sp>
+      <p:sp>
+        <p:nvSpPr>
+          <p:cNvPr id="10" name="TextBox 9"/>
+          <p:cNvSpPr txBox="1"/>
+          <p:nvPr/>
+        </p:nvSpPr>
+        <p:spPr>
+          <a:xfrm>
+            <a:off x="685800" y="3058160"/>
+            <a:ext cx="10820095" cy="513080"/>
+          </a:xfrm>
+          <a:prstGeom prst="rect">
+            <a:avLst/>
+          </a:prstGeom>
+          <a:noFill/>
+        </p:spPr>
+        <p:txBody>
+          <a:bodyPr wrap="square" anchor="t" lIns="0" rIns="0" tIns="0" bIns="0">
+            <a:spAutoFit/>
+          </a:bodyPr>
+          <a:lstStyle/>
+          <a:p>
+            <a:pPr>
+              <a:spcAft>
+                <a:spcPts val="800"/>
+              </a:spcAft>
+            </a:pPr>
+            <a:r>
+              <a:rPr sz="1700" b="0">
+                <a:solidFill>
+                  <a:srgbClr val="1C1C1A"/>
+                </a:solidFill>
+                <a:latin typeface="Calibri"/>
+              </a:rPr>
+              <a:t>Issue 3 adds 6 and issue 7 adds 7: 13, the same number the function returned.</a:t>
+            </a:r>
+          </a:p>
+        </p:txBody>
+      </p:sp>
       <p:pic>
         <p:nvPicPr>
-          <p:cNvPr id="7" name="Picture 6" descr="d9f5d5431a93de8d.png"/>
+          <p:cNvPr id="11" name="Picture 10" descr="223aefecd6db2d61.png"/>
           <p:cNvPicPr>
             <a:picLocks noChangeAspect="1"/>
           </p:cNvPicPr>
@@ -5809,228 +6023,14 @@
         </p:blipFill>
         <p:spPr>
           <a:xfrm>
-            <a:off x="685800" y="3245975"/>
-            <a:ext cx="4652640" cy="1189008"/>
+            <a:off x="1042269" y="3699256"/>
+            <a:ext cx="10107156" cy="2354072"/>
           </a:xfrm>
           <a:prstGeom prst="rect">
             <a:avLst/>
           </a:prstGeom>
         </p:spPr>
       </p:pic>
-      <p:sp>
-        <p:nvSpPr>
-          <p:cNvPr id="8" name="Rectangle 7"/>
-          <p:cNvSpPr/>
-          <p:nvPr/>
-        </p:nvSpPr>
-        <p:spPr>
-          <a:xfrm>
-            <a:off x="5771244" y="2597912"/>
-            <a:ext cx="5734650" cy="1410208"/>
-          </a:xfrm>
-          <a:prstGeom prst="rect">
-            <a:avLst/>
-          </a:prstGeom>
-          <a:solidFill>
-            <a:srgbClr val="1C1C1A"/>
-          </a:solidFill>
-          <a:ln>
-            <a:noFill/>
-          </a:ln>
-          <a:effectLst/>
-        </p:spPr>
-        <p:style>
-          <a:lnRef idx="1">
-            <a:schemeClr val="accent1"/>
-          </a:lnRef>
-          <a:fillRef idx="3">
-            <a:schemeClr val="accent1"/>
-          </a:fillRef>
-          <a:effectRef idx="2">
-            <a:schemeClr val="accent1"/>
-          </a:effectRef>
-          <a:fontRef idx="minor">
-            <a:schemeClr val="lt1"/>
-          </a:fontRef>
-        </p:style>
-        <p:txBody>
-          <a:bodyPr rtlCol="0" anchor="ctr" wrap="square"/>
-          <a:lstStyle/>
-          <a:p>
-            <a:pPr algn="ctr"/>
-          </a:p>
-        </p:txBody>
-      </p:sp>
-      <p:sp>
-        <p:nvSpPr>
-          <p:cNvPr id="9" name="Rectangle 8"/>
-          <p:cNvSpPr/>
-          <p:nvPr/>
-        </p:nvSpPr>
-        <p:spPr>
-          <a:xfrm>
-            <a:off x="5771244" y="2597912"/>
-            <a:ext cx="50292" cy="1410208"/>
-          </a:xfrm>
-          <a:prstGeom prst="rect">
-            <a:avLst/>
-          </a:prstGeom>
-          <a:solidFill>
-            <a:srgbClr val="2B4A7D"/>
-          </a:solidFill>
-          <a:ln>
-            <a:noFill/>
-          </a:ln>
-          <a:effectLst/>
-        </p:spPr>
-        <p:style>
-          <a:lnRef idx="1">
-            <a:schemeClr val="accent1"/>
-          </a:lnRef>
-          <a:fillRef idx="3">
-            <a:schemeClr val="accent1"/>
-          </a:fillRef>
-          <a:effectRef idx="2">
-            <a:schemeClr val="accent1"/>
-          </a:effectRef>
-          <a:fontRef idx="minor">
-            <a:schemeClr val="lt1"/>
-          </a:fontRef>
-        </p:style>
-        <p:txBody>
-          <a:bodyPr rtlCol="0" anchor="ctr" wrap="square"/>
-          <a:lstStyle/>
-          <a:p>
-            <a:pPr algn="ctr"/>
-          </a:p>
-        </p:txBody>
-      </p:sp>
-      <p:sp>
-        <p:nvSpPr>
-          <p:cNvPr id="10" name="TextBox 9"/>
-          <p:cNvSpPr txBox="1"/>
-          <p:nvPr/>
-        </p:nvSpPr>
-        <p:spPr>
-          <a:xfrm>
-            <a:off x="6008988" y="2698496"/>
-            <a:ext cx="5332314" cy="1227328"/>
-          </a:xfrm>
-          <a:prstGeom prst="rect">
-            <a:avLst/>
-          </a:prstGeom>
-          <a:noFill/>
-        </p:spPr>
-        <p:txBody>
-          <a:bodyPr wrap="square" anchor="t" lIns="0" rIns="0" tIns="0" bIns="0">
-            <a:spAutoFit/>
-          </a:bodyPr>
-          <a:lstStyle/>
-          <a:p>
-            <a:pPr>
-              <a:spcAft>
-                <a:spcPts val="200"/>
-              </a:spcAft>
-            </a:pPr>
-            <a:r>
-              <a:rPr sz="1600" b="0">
-                <a:solidFill>
-                  <a:srgbClr val="E4ECF7"/>
-                </a:solidFill>
-                <a:latin typeface="Consolas"/>
-              </a:rPr>
-              <a:t>SELECT SUM(days_kept - 14) AS late_days</a:t>
-            </a:r>
-          </a:p>
-          <a:p>
-            <a:pPr>
-              <a:spcAft>
-                <a:spcPts val="200"/>
-              </a:spcAft>
-            </a:pPr>
-            <a:r>
-              <a:rPr sz="1600" b="0">
-                <a:solidFill>
-                  <a:srgbClr val="E4ECF7"/>
-                </a:solidFill>
-                <a:latin typeface="Consolas"/>
-              </a:rPr>
-              <a:t>FROM issues</a:t>
-            </a:r>
-          </a:p>
-          <a:p>
-            <a:pPr>
-              <a:spcAft>
-                <a:spcPts val="200"/>
-              </a:spcAft>
-            </a:pPr>
-            <a:r>
-              <a:rPr sz="1600" b="0">
-                <a:solidFill>
-                  <a:srgbClr val="E4ECF7"/>
-                </a:solidFill>
-                <a:latin typeface="Consolas"/>
-              </a:rPr>
-              <a:t>WHERE week = 1</a:t>
-            </a:r>
-          </a:p>
-          <a:p>
-            <a:pPr>
-              <a:spcAft>
-                <a:spcPts val="200"/>
-              </a:spcAft>
-            </a:pPr>
-            <a:r>
-              <a:rPr sz="1600" b="0">
-                <a:solidFill>
-                  <a:srgbClr val="E4ECF7"/>
-                </a:solidFill>
-                <a:latin typeface="Consolas"/>
-              </a:rPr>
-              <a:t>  AND days_kept &gt; 14;        -- 13</a:t>
-            </a:r>
-          </a:p>
-        </p:txBody>
-      </p:sp>
-      <p:sp>
-        <p:nvSpPr>
-          <p:cNvPr id="11" name="TextBox 10"/>
-          <p:cNvSpPr txBox="1"/>
-          <p:nvPr/>
-        </p:nvSpPr>
-        <p:spPr>
-          <a:xfrm>
-            <a:off x="5771244" y="4172712"/>
-            <a:ext cx="5734650" cy="910336"/>
-          </a:xfrm>
-          <a:prstGeom prst="rect">
-            <a:avLst/>
-          </a:prstGeom>
-          <a:noFill/>
-        </p:spPr>
-        <p:txBody>
-          <a:bodyPr wrap="square" anchor="t" lIns="0" rIns="0" tIns="0" bIns="0">
-            <a:spAutoFit/>
-          </a:bodyPr>
-          <a:lstStyle/>
-          <a:p>
-            <a:pPr>
-              <a:spcAft>
-                <a:spcPts val="900"/>
-              </a:spcAft>
-            </a:pPr>
-            <a:r>
-              <a:rPr sz="2000" b="0">
-                <a:solidFill>
-                  <a:srgbClr val="1C1C1A"/>
-                </a:solidFill>
-                <a:latin typeface="Calibri"/>
-              </a:rPr>
-              <a:t>Issue 3 adds 6 and issue 7 adds 7: 13, the same number the function returned.</a:t>
-            </a:r>
-          </a:p>
-        </p:txBody>
-      </p:sp>
       <p:sp>
         <p:nvSpPr>
           <p:cNvPr id="12" name="Rectangle 11"/>

</xml_diff>